<commit_message>
feat: add local web demo link button to slide 7
</commit_message>
<xml_diff>
--- a/Presentasi_Resep_Masakan.pptx
+++ b/Presentasi_Resep_Masakan.pptx
@@ -6523,7 +6523,7 @@
         <p:spPr>
           <a:xfrm>
             <a:off x="731520" y="1463040"/>
-            <a:ext cx="3364992" cy="4663440"/>
+            <a:ext cx="3364992" cy="3657600"/>
           </a:xfrm>
           <a:prstGeom prst="roundRect">
             <a:avLst/>
@@ -6610,8 +6610,8 @@
         </p:nvSpPr>
         <p:spPr>
           <a:xfrm>
-            <a:off x="960120" y="1737360"/>
-            <a:ext cx="2907792" cy="4206240"/>
+            <a:off x="960120" y="1691640"/>
+            <a:ext cx="2907792" cy="3291840"/>
           </a:xfrm>
           <a:prstGeom prst="rect">
             <a:avLst/>
@@ -6626,7 +6626,7 @@
           <a:p>
             <a:pPr>
               <a:spcAft>
-                <a:spcPts val="1400"/>
+                <a:spcPts val="1200"/>
               </a:spcAft>
               <a:defRPr sz="1700" b="1">
                 <a:solidFill>
@@ -6641,9 +6641,9 @@
           <a:p>
             <a:pPr>
               <a:spcAft>
-                <a:spcPts val="1000"/>
+                <a:spcPts val="800"/>
               </a:spcAft>
-              <a:defRPr sz="1300">
+              <a:defRPr sz="1200">
                 <a:solidFill>
                   <a:srgbClr val="231F20"/>
                 </a:solidFill>
@@ -6656,9 +6656,9 @@
           <a:p>
             <a:pPr>
               <a:spcAft>
-                <a:spcPts val="1000"/>
+                <a:spcPts val="800"/>
               </a:spcAft>
-              <a:defRPr sz="1300">
+              <a:defRPr sz="1200">
                 <a:solidFill>
                   <a:srgbClr val="231F20"/>
                 </a:solidFill>
@@ -6671,9 +6671,9 @@
           <a:p>
             <a:pPr>
               <a:spcAft>
-                <a:spcPts val="1000"/>
+                <a:spcPts val="800"/>
               </a:spcAft>
-              <a:defRPr sz="1300">
+              <a:defRPr sz="1200">
                 <a:solidFill>
                   <a:srgbClr val="231F20"/>
                 </a:solidFill>
@@ -6694,7 +6694,7 @@
         <p:spPr>
           <a:xfrm>
             <a:off x="4407407" y="1463040"/>
-            <a:ext cx="3364992" cy="4663440"/>
+            <a:ext cx="3364992" cy="3657600"/>
           </a:xfrm>
           <a:prstGeom prst="roundRect">
             <a:avLst/>
@@ -6781,8 +6781,8 @@
         </p:nvSpPr>
         <p:spPr>
           <a:xfrm>
-            <a:off x="4636007" y="1737360"/>
-            <a:ext cx="2907792" cy="4206240"/>
+            <a:off x="4636007" y="1691640"/>
+            <a:ext cx="2907792" cy="3291840"/>
           </a:xfrm>
           <a:prstGeom prst="rect">
             <a:avLst/>
@@ -6797,7 +6797,7 @@
           <a:p>
             <a:pPr>
               <a:spcAft>
-                <a:spcPts val="1400"/>
+                <a:spcPts val="1200"/>
               </a:spcAft>
               <a:defRPr sz="1700" b="1">
                 <a:solidFill>
@@ -6812,9 +6812,9 @@
           <a:p>
             <a:pPr>
               <a:spcAft>
-                <a:spcPts val="1000"/>
+                <a:spcPts val="800"/>
               </a:spcAft>
-              <a:defRPr sz="1300">
+              <a:defRPr sz="1200">
                 <a:solidFill>
                   <a:srgbClr val="231F20"/>
                 </a:solidFill>
@@ -6827,9 +6827,9 @@
           <a:p>
             <a:pPr>
               <a:spcAft>
-                <a:spcPts val="1000"/>
+                <a:spcPts val="800"/>
               </a:spcAft>
-              <a:defRPr sz="1300">
+              <a:defRPr sz="1200">
                 <a:solidFill>
                   <a:srgbClr val="231F20"/>
                 </a:solidFill>
@@ -6842,9 +6842,9 @@
           <a:p>
             <a:pPr>
               <a:spcAft>
-                <a:spcPts val="1000"/>
+                <a:spcPts val="800"/>
               </a:spcAft>
-              <a:defRPr sz="1300">
+              <a:defRPr sz="1200">
                 <a:solidFill>
                   <a:srgbClr val="231F20"/>
                 </a:solidFill>
@@ -6865,7 +6865,7 @@
         <p:spPr>
           <a:xfrm>
             <a:off x="8083296" y="1463040"/>
-            <a:ext cx="3364992" cy="4663440"/>
+            <a:ext cx="3364992" cy="3657600"/>
           </a:xfrm>
           <a:prstGeom prst="roundRect">
             <a:avLst/>
@@ -6952,8 +6952,8 @@
         </p:nvSpPr>
         <p:spPr>
           <a:xfrm>
-            <a:off x="8311896" y="1737360"/>
-            <a:ext cx="2907792" cy="4206240"/>
+            <a:off x="8311896" y="1691640"/>
+            <a:ext cx="2907792" cy="3291840"/>
           </a:xfrm>
           <a:prstGeom prst="rect">
             <a:avLst/>
@@ -6968,7 +6968,7 @@
           <a:p>
             <a:pPr>
               <a:spcAft>
-                <a:spcPts val="1400"/>
+                <a:spcPts val="1200"/>
               </a:spcAft>
               <a:defRPr sz="1700" b="1">
                 <a:solidFill>
@@ -6983,9 +6983,9 @@
           <a:p>
             <a:pPr>
               <a:spcAft>
-                <a:spcPts val="1000"/>
+                <a:spcPts val="800"/>
               </a:spcAft>
-              <a:defRPr sz="1300">
+              <a:defRPr sz="1200">
                 <a:solidFill>
                   <a:srgbClr val="231F20"/>
                 </a:solidFill>
@@ -6998,9 +6998,9 @@
           <a:p>
             <a:pPr>
               <a:spcAft>
-                <a:spcPts val="1000"/>
+                <a:spcPts val="800"/>
               </a:spcAft>
-              <a:defRPr sz="1300">
+              <a:defRPr sz="1200">
                 <a:solidFill>
                   <a:srgbClr val="231F20"/>
                 </a:solidFill>
@@ -7013,9 +7013,9 @@
           <a:p>
             <a:pPr>
               <a:spcAft>
-                <a:spcPts val="1000"/>
+                <a:spcPts val="800"/>
               </a:spcAft>
-              <a:defRPr sz="1300">
+              <a:defRPr sz="1200">
                 <a:solidFill>
                   <a:srgbClr val="231F20"/>
                 </a:solidFill>
@@ -7023,6 +7023,58 @@
             </a:pPr>
             <a:r>
               <a:t>• Dukungan multi-bahasa.</a:t>
+            </a:r>
+          </a:p>
+        </p:txBody>
+      </p:sp>
+      <p:sp>
+        <p:nvSpPr>
+          <p:cNvPr id="14" name="Rounded Rectangle 13"/>
+          <p:cNvSpPr/>
+          <p:nvPr/>
+        </p:nvSpPr>
+        <p:spPr>
+          <a:xfrm>
+            <a:off x="3474720" y="5440680"/>
+            <a:ext cx="5212080" cy="777240"/>
+          </a:xfrm>
+          <a:prstGeom prst="roundRect">
+            <a:avLst/>
+          </a:prstGeom>
+          <a:solidFill>
+            <a:srgbClr val="B43214"/>
+          </a:solidFill>
+          <a:ln>
+            <a:noFill/>
+          </a:ln>
+        </p:spPr>
+        <p:style>
+          <a:lnRef idx="1">
+            <a:schemeClr val="accent1"/>
+          </a:lnRef>
+          <a:fillRef idx="3">
+            <a:schemeClr val="accent1"/>
+          </a:fillRef>
+          <a:effectRef idx="2">
+            <a:schemeClr val="accent1"/>
+          </a:effectRef>
+          <a:fontRef idx="minor">
+            <a:schemeClr val="lt1"/>
+          </a:fontRef>
+        </p:style>
+        <p:txBody>
+          <a:bodyPr rtlCol="0" anchor="ctr" wrap="square"/>
+          <a:lstStyle/>
+          <a:p>
+            <a:pPr algn="ctr"/>
+            <a:r>
+              <a:rPr sz="1400" b="1">
+                <a:solidFill>
+                  <a:srgbClr val="FFFFFF"/>
+                </a:solidFill>
+                <a:hlinkClick r:id="rId2"/>
+              </a:rPr>
+              <a:t>🌐 BUKA DEMO WEB LOKAL (127.0.0.1:8000)</a:t>
             </a:r>
           </a:p>
         </p:txBody>

</xml_diff>